<commit_message>
Story PPTs now mirror the in-page story panels (titles, bodies, mission, punchline); add PPT download links
Co-authored-by: Copilot <223556219+Copilot@users.noreply.github.com>
</commit_message>
<xml_diff>
--- a/Contoso Power Story - 10 June (Executive).pptx
+++ b/Contoso Power Story - 10 June (Executive).pptx
@@ -3527,7 +3527,7 @@
                 </a:solidFill>
                 <a:latin typeface="Segoe UI"/>
               </a:rPr>
-              <a:t>1:30pm — fresh ASEAN energy market scan.</a:t>
+              <a:t>Board meets Friday. This afternoon:</a:t>
             </a:r>
           </a:p>
           <a:p>
@@ -3539,7 +3539,7 @@
                 </a:solidFill>
                 <a:latin typeface="Segoe UI"/>
               </a:rPr>
-              <a:t>2:30pm — peer benchmark &amp; financial commentary.</a:t>
+              <a:t>build the renewables JV case from market evidence,</a:t>
             </a:r>
           </a:p>
           <a:p>
@@ -3551,7 +3551,7 @@
                 </a:solidFill>
                 <a:latin typeface="Segoe UI"/>
               </a:rPr>
-              <a:t>3:30pm — board paper for the renewables JV.</a:t>
+              <a:t>benchmark against listed peers, draft the board paper,</a:t>
             </a:r>
           </a:p>
           <a:p>
@@ -3563,7 +3563,7 @@
                 </a:solidFill>
                 <a:latin typeface="Segoe UI"/>
               </a:rPr>
-              <a:t>4:30pm — investor pack ready for Friday's announcement.</a:t>
+              <a:t>prepare the investor announcement for the moment the Board says yes.</a:t>
             </a:r>
           </a:p>
         </p:txBody>
@@ -3678,7 +3678,19 @@
                 </a:solidFill>
                 <a:latin typeface="Segoe UI"/>
               </a:rPr>
-              <a:t>From market scan to investor announcement — in one afternoon.</a:t>
+              <a:t>One afternoon.</a:t>
+            </a:r>
+          </a:p>
+          <a:p>
+            <a:pPr algn="l"/>
+            <a:r>
+              <a:rPr sz="1300" b="1">
+                <a:solidFill>
+                  <a:srgbClr val="FFFFFF"/>
+                </a:solidFill>
+                <a:latin typeface="Segoe UI"/>
+              </a:rPr>
+              <a:t>From market scan to investor announcement.</a:t>
             </a:r>
           </a:p>
         </p:txBody>
@@ -3906,7 +3918,7 @@
                 </a:solidFill>
                 <a:latin typeface="Segoe UI"/>
               </a:rPr>
-              <a:t>RESEARCHER  ·  EXCEL COPILOT</a:t>
+              <a:t>RESEARCHER (CRITIQUE)</a:t>
             </a:r>
           </a:p>
         </p:txBody>
@@ -4013,13 +4025,13 @@
           <a:p>
             <a:pPr algn="l"/>
             <a:r>
-              <a:rPr sz="1300" b="1">
+              <a:rPr sz="1250" b="1">
                 <a:solidFill>
                   <a:srgbClr val="1A202C"/>
                 </a:solidFill>
                 <a:latin typeface="Segoe UI"/>
               </a:rPr>
-              <a:t>ASEAN market scan</a:t>
+              <a:t>Scan the landscape — sources verified</a:t>
             </a:r>
           </a:p>
         </p:txBody>
@@ -4048,25 +4060,13 @@
           <a:p>
             <a:pPr algn="l"/>
             <a:r>
-              <a:rPr sz="900" b="0">
+              <a:rPr sz="1000" b="0">
                 <a:solidFill>
                   <a:srgbClr val="64748B"/>
                 </a:solidFill>
                 <a:latin typeface="Segoe UI"/>
               </a:rPr>
-              <a:t>CORE · Researcher (Critique mode) — multi-source scan: ASEAN demand outlook, NETR &amp; CRESS implications, peer moves (TNB, YTL, Sembcorp, AboitizPower), data-centre captive power thesis. Sources auto-reviewed.</a:t>
-            </a:r>
-          </a:p>
-          <a:p>
-            <a:pPr algn="l"/>
-            <a:r>
-              <a:rPr sz="900" b="0">
-                <a:solidFill>
-                  <a:srgbClr val="64748B"/>
-                </a:solidFill>
-                <a:latin typeface="Segoe UI"/>
-              </a:rPr>
-              <a:t>STRETCH · Excel Copilot — turn the scan into a market-context comparison table for the board paper appendix.</a:t>
+              <a:t>ASEAN power demand outlook, NETR &amp; CRESS implications, peer moves (TNB, YTL, Sembcorp, AboitizPower), data centre captive power thesis. Critique auto-reviews source reliability before producing the report.</a:t>
             </a:r>
           </a:p>
         </p:txBody>
@@ -4224,7 +4224,7 @@
                 </a:solidFill>
                 <a:latin typeface="Segoe UI"/>
               </a:rPr>
-              <a:t>ANALYST  ·  TEAMS RECAP  ·  WORD COPILOT  ·  PLANNER AGENT</a:t>
+              <a:t>ANALYST (AGENT)</a:t>
             </a:r>
           </a:p>
         </p:txBody>
@@ -4331,13 +4331,13 @@
           <a:p>
             <a:pPr algn="l"/>
             <a:r>
-              <a:rPr sz="1300" b="1">
+              <a:rPr sz="1250" b="1">
                 <a:solidFill>
                   <a:srgbClr val="1A202C"/>
                 </a:solidFill>
                 <a:latin typeface="Segoe UI"/>
               </a:rPr>
-              <a:t>Financial benchmark &amp; CFO pre-board</a:t>
+              <a:t>Where Contoso Power screens</a:t>
             </a:r>
           </a:p>
         </p:txBody>
@@ -4366,25 +4366,13 @@
           <a:p>
             <a:pPr algn="l"/>
             <a:r>
-              <a:rPr sz="900" b="0">
+              <a:rPr sz="1000" b="0">
                 <a:solidFill>
                   <a:srgbClr val="64748B"/>
                 </a:solidFill>
                 <a:latin typeface="Segoe UI"/>
               </a:rPr>
-              <a:t>CORE · Analyst — EV/EBITDA, leverage, renewables mix vs listed peers; Group P&amp;L trend; plain-English translation for non-financial directors.</a:t>
-            </a:r>
-          </a:p>
-          <a:p>
-            <a:pPr algn="l"/>
-            <a:r>
-              <a:rPr sz="900" b="0">
-                <a:solidFill>
-                  <a:srgbClr val="64748B"/>
-                </a:solidFill>
-                <a:latin typeface="Segoe UI"/>
-              </a:rPr>
-              <a:t>STRETCH · Teams Recap + Word Copilot — CFO pre-board call recap into formal notes · Planner agent — Board Q&amp;A tracker for every question raised.</a:t>
+              <a:t>EV/EBITDA, leverage, renewables mix vs listed peers. EBITDA margin trend, capex intensity, net debt progression. Translates back to plain English for the non-financial Board reader.</a:t>
             </a:r>
           </a:p>
         </p:txBody>
@@ -4542,7 +4530,7 @@
                 </a:solidFill>
                 <a:latin typeface="Segoe UI"/>
               </a:rPr>
-              <a:t>WORD COPILOT  ·  POWERPOINT AGENT  ·  EXCEL AGENT  ·  WORD AGENT  ·  POWERPOINT COPILOT</a:t>
+              <a:t>WORD COPILOT  →  POWERPOINT AGENT</a:t>
             </a:r>
           </a:p>
         </p:txBody>
@@ -4649,13 +4637,13 @@
           <a:p>
             <a:pPr algn="l"/>
             <a:r>
-              <a:rPr sz="1300" b="1">
+              <a:rPr sz="1250" b="1">
                 <a:solidFill>
                   <a:srgbClr val="1A202C"/>
                 </a:solidFill>
                 <a:latin typeface="Segoe UI"/>
               </a:rPr>
-              <a:t>Board paper · Renewables JV</a:t>
+              <a:t>Board paper → board deck</a:t>
             </a:r>
           </a:p>
         </p:txBody>
@@ -4684,25 +4672,13 @@
           <a:p>
             <a:pPr algn="l"/>
             <a:r>
-              <a:rPr sz="900" b="0">
+              <a:rPr sz="1000" b="0">
                 <a:solidFill>
                   <a:srgbClr val="64748B"/>
                 </a:solidFill>
                 <a:latin typeface="Segoe UI"/>
               </a:rPr>
-              <a:t>CORE · Word Copilot — 500 MW solar + 200 MWh BESS board paper grounded on the market scan, with a Legal regulatory overlay.</a:t>
-            </a:r>
-          </a:p>
-          <a:p>
-            <a:pPr algn="l"/>
-            <a:r>
-              <a:rPr sz="900" b="0">
-                <a:solidFill>
-                  <a:srgbClr val="64748B"/>
-                </a:solidFill>
-                <a:latin typeface="Segoe UI"/>
-              </a:rPr>
-              <a:t>STRETCH · PowerPoint agent — 10-slide board deck · Excel agent — financial summary workbook · Word agent — one-shot alt draft · PowerPoint Copilot — in-app deck refinement.</a:t>
+              <a:t>500 MW solar + 200 MWh BESS JV. Strategic rationale grounded in the market scan; structure, financials, four key risks (with a Legal regulatory overlay), recommendation. PowerPoint agent then turns it into a 10-slide board deck with speaker notes.</a:t>
             </a:r>
           </a:p>
         </p:txBody>
@@ -4967,13 +4943,13 @@
           <a:p>
             <a:pPr algn="l"/>
             <a:r>
-              <a:rPr sz="1300" b="1">
+              <a:rPr sz="1250" b="1">
                 <a:solidFill>
                   <a:srgbClr val="1A202C"/>
                 </a:solidFill>
                 <a:latin typeface="Segoe UI"/>
               </a:rPr>
-              <a:t>Investor pack + executive dashboard</a:t>
+              <a:t>Press kit + executive dashboard</a:t>
             </a:r>
           </a:p>
         </p:txBody>
@@ -5002,13 +4978,13 @@
           <a:p>
             <a:pPr algn="l"/>
             <a:r>
-              <a:rPr sz="900" b="0">
+              <a:rPr sz="1000" b="0">
                 <a:solidFill>
                   <a:srgbClr val="64748B"/>
                 </a:solidFill>
                 <a:latin typeface="Segoe UI"/>
               </a:rPr>
-              <a:t>CORE · Cowork — brand guidelines + financials uploaded once. Four brand-aligned deliverables in one delegation: Bursa-style announcement, single-file HTML investor microsite, a workable executive HTML dashboard (Chart.js KPIs + trend + donut + capex bar), and a CEO LinkedIn post.</a:t>
+              <a:t>Brand guidelines + financial workbook uploaded. Cowork produces: Bursa-style announcement, single-file HTML investor microsite, a workable executive HTML dashboard (Chart.js KPIs, trends, donut), and a CEO LinkedIn post — all brand-aligned.</a:t>
             </a:r>
           </a:p>
         </p:txBody>

</xml_diff>

<commit_message>
Story panels + PPT now both list every Copilot surface per exercise (CORE + STRETCH); replace .txt files with .docx
Co-authored-by: Copilot <223556219+Copilot@users.noreply.github.com>
</commit_message>
<xml_diff>
--- a/Contoso Power Story - 10 June (Executive).pptx
+++ b/Contoso Power Story - 10 June (Executive).pptx
@@ -3918,7 +3918,7 @@
                 </a:solidFill>
                 <a:latin typeface="Segoe UI"/>
               </a:rPr>
-              <a:t>RESEARCHER (CRITIQUE)</a:t>
+              <a:t>RESEARCHER  +  EXCEL COPILOT</a:t>
             </a:r>
           </a:p>
         </p:txBody>
@@ -4010,7 +4010,7 @@
         <p:spPr>
           <a:xfrm>
             <a:off x="4096512" y="1874520"/>
-            <a:ext cx="3611880" cy="365760"/>
+            <a:ext cx="3611880" cy="320040"/>
           </a:xfrm>
           <a:prstGeom prst="rect">
             <a:avLst/>
@@ -4025,13 +4025,13 @@
           <a:p>
             <a:pPr algn="l"/>
             <a:r>
-              <a:rPr sz="1250" b="1">
+              <a:rPr sz="1200" b="1">
                 <a:solidFill>
                   <a:srgbClr val="1A202C"/>
                 </a:solidFill>
                 <a:latin typeface="Segoe UI"/>
               </a:rPr>
-              <a:t>Scan the landscape — sources verified</a:t>
+              <a:t>ASEAN market scan</a:t>
             </a:r>
           </a:p>
         </p:txBody>
@@ -4044,8 +4044,8 @@
         </p:nvSpPr>
         <p:spPr>
           <a:xfrm>
-            <a:off x="4096512" y="2267712"/>
-            <a:ext cx="3611880" cy="1463040"/>
+            <a:off x="4096512" y="2212848"/>
+            <a:ext cx="3611880" cy="1508760"/>
           </a:xfrm>
           <a:prstGeom prst="rect">
             <a:avLst/>
@@ -4060,13 +4060,25 @@
           <a:p>
             <a:pPr algn="l"/>
             <a:r>
-              <a:rPr sz="1000" b="0">
+              <a:rPr sz="900" b="0">
                 <a:solidFill>
                   <a:srgbClr val="64748B"/>
                 </a:solidFill>
                 <a:latin typeface="Segoe UI"/>
               </a:rPr>
-              <a:t>ASEAN power demand outlook, NETR &amp; CRESS implications, peer moves (TNB, YTL, Sembcorp, AboitizPower), data centre captive power thesis. Critique auto-reviews source reliability before producing the report.</a:t>
+              <a:t>CORE · Researcher (Critique) — ASEAN demand, NETR &amp; CRESS, peer moves (TNB/YTL/Sembcorp/AboitizPower), data-centre captive power thesis; sources auto-reviewed.</a:t>
+            </a:r>
+          </a:p>
+          <a:p>
+            <a:pPr algn="l"/>
+            <a:r>
+              <a:rPr sz="900" b="0">
+                <a:solidFill>
+                  <a:srgbClr val="64748B"/>
+                </a:solidFill>
+                <a:latin typeface="Segoe UI"/>
+              </a:rPr>
+              <a:t>STRETCH · Excel Copilot — turn the scan into a market-context comparison table for the appendix.</a:t>
             </a:r>
           </a:p>
         </p:txBody>
@@ -4224,7 +4236,7 @@
                 </a:solidFill>
                 <a:latin typeface="Segoe UI"/>
               </a:rPr>
-              <a:t>ANALYST (AGENT)</a:t>
+              <a:t>ANALYST  +  3 MORE</a:t>
             </a:r>
           </a:p>
         </p:txBody>
@@ -4316,7 +4328,7 @@
         <p:spPr>
           <a:xfrm>
             <a:off x="8119872" y="1874520"/>
-            <a:ext cx="3611880" cy="365760"/>
+            <a:ext cx="3611880" cy="320040"/>
           </a:xfrm>
           <a:prstGeom prst="rect">
             <a:avLst/>
@@ -4331,13 +4343,13 @@
           <a:p>
             <a:pPr algn="l"/>
             <a:r>
-              <a:rPr sz="1250" b="1">
+              <a:rPr sz="1200" b="1">
                 <a:solidFill>
                   <a:srgbClr val="1A202C"/>
                 </a:solidFill>
                 <a:latin typeface="Segoe UI"/>
               </a:rPr>
-              <a:t>Where Contoso Power screens</a:t>
+              <a:t>Financial benchmark + CFO pre-board</a:t>
             </a:r>
           </a:p>
         </p:txBody>
@@ -4350,8 +4362,8 @@
         </p:nvSpPr>
         <p:spPr>
           <a:xfrm>
-            <a:off x="8119872" y="2267712"/>
-            <a:ext cx="3611880" cy="1463040"/>
+            <a:off x="8119872" y="2212848"/>
+            <a:ext cx="3611880" cy="1508760"/>
           </a:xfrm>
           <a:prstGeom prst="rect">
             <a:avLst/>
@@ -4366,13 +4378,25 @@
           <a:p>
             <a:pPr algn="l"/>
             <a:r>
-              <a:rPr sz="1000" b="0">
+              <a:rPr sz="900" b="0">
                 <a:solidFill>
                   <a:srgbClr val="64748B"/>
                 </a:solidFill>
                 <a:latin typeface="Segoe UI"/>
               </a:rPr>
-              <a:t>EV/EBITDA, leverage, renewables mix vs listed peers. EBITDA margin trend, capex intensity, net debt progression. Translates back to plain English for the non-financial Board reader.</a:t>
+              <a:t>CORE · Analyst — EV/EBITDA, leverage, renewables mix vs peers; Group P&amp;L trend; plain-English commentary for non-financial directors.</a:t>
+            </a:r>
+          </a:p>
+          <a:p>
+            <a:pPr algn="l"/>
+            <a:r>
+              <a:rPr sz="900" b="0">
+                <a:solidFill>
+                  <a:srgbClr val="64748B"/>
+                </a:solidFill>
+                <a:latin typeface="Segoe UI"/>
+              </a:rPr>
+              <a:t>STRETCH · Teams Recap of the CFO pre-board call → Word Copilot formal notes  ·  Planner agent — Board Q&amp;A tracker.</a:t>
             </a:r>
           </a:p>
         </p:txBody>
@@ -4530,7 +4554,7 @@
                 </a:solidFill>
                 <a:latin typeface="Segoe UI"/>
               </a:rPr>
-              <a:t>WORD COPILOT  →  POWERPOINT AGENT</a:t>
+              <a:t>WORD  +  4 MORE</a:t>
             </a:r>
           </a:p>
         </p:txBody>
@@ -4622,7 +4646,7 @@
         <p:spPr>
           <a:xfrm>
             <a:off x="4096512" y="4480560"/>
-            <a:ext cx="3611880" cy="365760"/>
+            <a:ext cx="3611880" cy="320040"/>
           </a:xfrm>
           <a:prstGeom prst="rect">
             <a:avLst/>
@@ -4637,13 +4661,13 @@
           <a:p>
             <a:pPr algn="l"/>
             <a:r>
-              <a:rPr sz="1250" b="1">
+              <a:rPr sz="1200" b="1">
                 <a:solidFill>
                   <a:srgbClr val="1A202C"/>
                 </a:solidFill>
                 <a:latin typeface="Segoe UI"/>
               </a:rPr>
-              <a:t>Board paper → board deck</a:t>
+              <a:t>Board paper · Renewables JV</a:t>
             </a:r>
           </a:p>
         </p:txBody>
@@ -4656,8 +4680,8 @@
         </p:nvSpPr>
         <p:spPr>
           <a:xfrm>
-            <a:off x="4096512" y="4873752"/>
-            <a:ext cx="3611880" cy="1463040"/>
+            <a:off x="4096512" y="4818888"/>
+            <a:ext cx="3611880" cy="1508760"/>
           </a:xfrm>
           <a:prstGeom prst="rect">
             <a:avLst/>
@@ -4672,13 +4696,25 @@
           <a:p>
             <a:pPr algn="l"/>
             <a:r>
-              <a:rPr sz="1000" b="0">
+              <a:rPr sz="900" b="0">
                 <a:solidFill>
                   <a:srgbClr val="64748B"/>
                 </a:solidFill>
                 <a:latin typeface="Segoe UI"/>
               </a:rPr>
-              <a:t>500 MW solar + 200 MWh BESS JV. Strategic rationale grounded in the market scan; structure, financials, four key risks (with a Legal regulatory overlay), recommendation. PowerPoint agent then turns it into a 10-slide board deck with speaker notes.</a:t>
+              <a:t>CORE · Word Copilot — 500 MW solar + 200 MWh BESS board paper grounded on the scan, with Legal regulatory overlay.</a:t>
+            </a:r>
+          </a:p>
+          <a:p>
+            <a:pPr algn="l"/>
+            <a:r>
+              <a:rPr sz="900" b="0">
+                <a:solidFill>
+                  <a:srgbClr val="64748B"/>
+                </a:solidFill>
+                <a:latin typeface="Segoe UI"/>
+              </a:rPr>
+              <a:t>STRETCH · PowerPoint agent — 10-slide board deck  ·  Excel agent — financial summary workbook  ·  Word agent — one-shot alt draft  ·  PowerPoint Copilot — in-app deck refinement.</a:t>
             </a:r>
           </a:p>
         </p:txBody>
@@ -4928,7 +4964,7 @@
         <p:spPr>
           <a:xfrm>
             <a:off x="8119872" y="4480560"/>
-            <a:ext cx="3611880" cy="365760"/>
+            <a:ext cx="3611880" cy="320040"/>
           </a:xfrm>
           <a:prstGeom prst="rect">
             <a:avLst/>
@@ -4943,13 +4979,13 @@
           <a:p>
             <a:pPr algn="l"/>
             <a:r>
-              <a:rPr sz="1250" b="1">
+              <a:rPr sz="1200" b="1">
                 <a:solidFill>
                   <a:srgbClr val="1A202C"/>
                 </a:solidFill>
                 <a:latin typeface="Segoe UI"/>
               </a:rPr>
-              <a:t>Press kit + executive dashboard</a:t>
+              <a:t>Investor pack + executive dashboard</a:t>
             </a:r>
           </a:p>
         </p:txBody>
@@ -4962,8 +4998,8 @@
         </p:nvSpPr>
         <p:spPr>
           <a:xfrm>
-            <a:off x="8119872" y="4873752"/>
-            <a:ext cx="3611880" cy="1463040"/>
+            <a:off x="8119872" y="4818888"/>
+            <a:ext cx="3611880" cy="1508760"/>
           </a:xfrm>
           <a:prstGeom prst="rect">
             <a:avLst/>
@@ -4978,13 +5014,13 @@
           <a:p>
             <a:pPr algn="l"/>
             <a:r>
-              <a:rPr sz="1000" b="0">
+              <a:rPr sz="900" b="0">
                 <a:solidFill>
                   <a:srgbClr val="64748B"/>
                 </a:solidFill>
                 <a:latin typeface="Segoe UI"/>
               </a:rPr>
-              <a:t>Brand guidelines + financial workbook uploaded. Cowork produces: Bursa-style announcement, single-file HTML investor microsite, a workable executive HTML dashboard (Chart.js KPIs, trends, donut), and a CEO LinkedIn post — all brand-aligned.</a:t>
+              <a:t>CORE · Cowork — brand guidelines + financials uploaded once. Four brand-aligned deliverables in one delegation: Bursa-style announcement, single-file HTML investor microsite, a workable Chart.js executive dashboard, and a CEO LinkedIn post.</a:t>
             </a:r>
           </a:p>
         </p:txBody>

</xml_diff>

<commit_message>
Story split under each session header; drop exercise number + duration pill; HTML cowork deliverables moved to end
Co-authored-by: Copilot <223556219+Copilot@users.noreply.github.com>
</commit_message>
<xml_diff>
--- a/Contoso Power Story - 10 June (Executive).pptx
+++ b/Contoso Power Story - 10 June (Executive).pptx
@@ -3861,8 +3861,8 @@
         </p:nvSpPr>
         <p:spPr>
           <a:xfrm>
-            <a:off x="4069080" y="1444752"/>
-            <a:ext cx="457200" cy="274320"/>
+            <a:off x="4096512" y="1463040"/>
+            <a:ext cx="3557016" cy="256032"/>
           </a:xfrm>
           <a:prstGeom prst="rect">
             <a:avLst/>
@@ -3877,13 +3877,13 @@
           <a:p>
             <a:pPr algn="l"/>
             <a:r>
-              <a:rPr sz="1300" b="1">
+              <a:rPr sz="1000" b="1">
                 <a:solidFill>
                   <a:srgbClr val="FFFFFF"/>
                 </a:solidFill>
                 <a:latin typeface="Segoe UI"/>
               </a:rPr>
-              <a:t>01</a:t>
+              <a:t>RESEARCHER  +  EXCEL COPILOT</a:t>
             </a:r>
           </a:p>
         </p:txBody>
@@ -3896,8 +3896,8 @@
         </p:nvSpPr>
         <p:spPr>
           <a:xfrm>
-            <a:off x="4480560" y="1472184"/>
-            <a:ext cx="2514600" cy="256032"/>
+            <a:off x="4096512" y="1874520"/>
+            <a:ext cx="3611880" cy="320040"/>
           </a:xfrm>
           <a:prstGeom prst="rect">
             <a:avLst/>
@@ -3912,27 +3912,74 @@
           <a:p>
             <a:pPr algn="l"/>
             <a:r>
-              <a:rPr sz="900" b="1">
-                <a:solidFill>
-                  <a:srgbClr val="FFFFFF"/>
+              <a:rPr sz="1250" b="1">
+                <a:solidFill>
+                  <a:srgbClr val="1A202C"/>
                 </a:solidFill>
                 <a:latin typeface="Segoe UI"/>
               </a:rPr>
-              <a:t>RESEARCHER  +  EXCEL COPILOT</a:t>
-            </a:r>
-          </a:p>
-        </p:txBody>
-      </p:sp>
-      <p:sp>
-        <p:nvSpPr>
-          <p:cNvPr id="23" name="Rounded Rectangle 22"/>
+              <a:t>ASEAN market scan</a:t>
+            </a:r>
+          </a:p>
+        </p:txBody>
+      </p:sp>
+      <p:sp>
+        <p:nvSpPr>
+          <p:cNvPr id="23" name="TextBox 22"/>
+          <p:cNvSpPr txBox="1"/>
+          <p:nvPr/>
+        </p:nvSpPr>
+        <p:spPr>
+          <a:xfrm>
+            <a:off x="4096512" y="2212848"/>
+            <a:ext cx="3611880" cy="1508760"/>
+          </a:xfrm>
+          <a:prstGeom prst="rect">
+            <a:avLst/>
+          </a:prstGeom>
+          <a:noFill/>
+        </p:spPr>
+        <p:txBody>
+          <a:bodyPr wrap="square" lIns="45720" rIns="45720" tIns="27432" bIns="27432" anchor="t">
+            <a:spAutoFit/>
+          </a:bodyPr>
+          <a:lstStyle/>
+          <a:p>
+            <a:pPr algn="l"/>
+            <a:r>
+              <a:rPr sz="950" b="0">
+                <a:solidFill>
+                  <a:srgbClr val="64748B"/>
+                </a:solidFill>
+                <a:latin typeface="Segoe UI"/>
+              </a:rPr>
+              <a:t>CORE · Researcher (Critique) — ASEAN demand, NETR &amp; CRESS, peer moves (TNB/YTL/Sembcorp/AboitizPower), data-centre captive power thesis; sources auto-reviewed.</a:t>
+            </a:r>
+          </a:p>
+          <a:p>
+            <a:pPr algn="l"/>
+            <a:r>
+              <a:rPr sz="950" b="0">
+                <a:solidFill>
+                  <a:srgbClr val="64748B"/>
+                </a:solidFill>
+                <a:latin typeface="Segoe UI"/>
+              </a:rPr>
+              <a:t>STRETCH · Excel Copilot — turn the scan into a market-context comparison table for the appendix.</a:t>
+            </a:r>
+          </a:p>
+        </p:txBody>
+      </p:sp>
+      <p:sp>
+        <p:nvSpPr>
+          <p:cNvPr id="24" name="Rounded Rectangle 23"/>
           <p:cNvSpPr/>
           <p:nvPr/>
         </p:nvSpPr>
         <p:spPr>
           <a:xfrm>
-            <a:off x="6949440" y="1453896"/>
-            <a:ext cx="731520" cy="256032"/>
+            <a:off x="7955280" y="1371600"/>
+            <a:ext cx="3886200" cy="2423160"/>
           </a:xfrm>
           <a:prstGeom prst="roundRect">
             <a:avLst/>
@@ -3940,8 +3987,10 @@
           <a:solidFill>
             <a:srgbClr val="FFFFFF"/>
           </a:solidFill>
-          <a:ln>
-            <a:noFill/>
+          <a:ln w="9525">
+            <a:solidFill>
+              <a:srgbClr val="D1D9E6"/>
+            </a:solidFill>
           </a:ln>
         </p:spPr>
         <p:style>
@@ -3968,142 +4017,23 @@
       </p:sp>
       <p:sp>
         <p:nvSpPr>
-          <p:cNvPr id="24" name="TextBox 23"/>
-          <p:cNvSpPr txBox="1"/>
+          <p:cNvPr id="25" name="Rectangle 24"/>
+          <p:cNvSpPr/>
           <p:nvPr/>
         </p:nvSpPr>
         <p:spPr>
           <a:xfrm>
-            <a:off x="6949440" y="1463040"/>
-            <a:ext cx="731520" cy="246888"/>
+            <a:off x="7955280" y="1371600"/>
+            <a:ext cx="3886200" cy="411480"/>
           </a:xfrm>
           <a:prstGeom prst="rect">
             <a:avLst/>
           </a:prstGeom>
-          <a:noFill/>
-        </p:spPr>
-        <p:txBody>
-          <a:bodyPr wrap="square" lIns="45720" rIns="45720" tIns="27432" bIns="27432" anchor="ctr">
-            <a:spAutoFit/>
-          </a:bodyPr>
-          <a:lstStyle/>
-          <a:p>
-            <a:pPr algn="ctr"/>
-            <a:r>
-              <a:rPr sz="850" b="1">
-                <a:solidFill>
-                  <a:srgbClr val="D97706"/>
-                </a:solidFill>
-                <a:latin typeface="Segoe UI"/>
-              </a:rPr>
-              <a:t>20 min</a:t>
-            </a:r>
-          </a:p>
-        </p:txBody>
-      </p:sp>
-      <p:sp>
-        <p:nvSpPr>
-          <p:cNvPr id="25" name="TextBox 24"/>
-          <p:cNvSpPr txBox="1"/>
-          <p:nvPr/>
-        </p:nvSpPr>
-        <p:spPr>
-          <a:xfrm>
-            <a:off x="4096512" y="1874520"/>
-            <a:ext cx="3611880" cy="320040"/>
-          </a:xfrm>
-          <a:prstGeom prst="rect">
-            <a:avLst/>
-          </a:prstGeom>
-          <a:noFill/>
-        </p:spPr>
-        <p:txBody>
-          <a:bodyPr wrap="square" lIns="45720" rIns="45720" tIns="27432" bIns="27432" anchor="t">
-            <a:spAutoFit/>
-          </a:bodyPr>
-          <a:lstStyle/>
-          <a:p>
-            <a:pPr algn="l"/>
-            <a:r>
-              <a:rPr sz="1200" b="1">
-                <a:solidFill>
-                  <a:srgbClr val="1A202C"/>
-                </a:solidFill>
-                <a:latin typeface="Segoe UI"/>
-              </a:rPr>
-              <a:t>ASEAN market scan</a:t>
-            </a:r>
-          </a:p>
-        </p:txBody>
-      </p:sp>
-      <p:sp>
-        <p:nvSpPr>
-          <p:cNvPr id="26" name="TextBox 25"/>
-          <p:cNvSpPr txBox="1"/>
-          <p:nvPr/>
-        </p:nvSpPr>
-        <p:spPr>
-          <a:xfrm>
-            <a:off x="4096512" y="2212848"/>
-            <a:ext cx="3611880" cy="1508760"/>
-          </a:xfrm>
-          <a:prstGeom prst="rect">
-            <a:avLst/>
-          </a:prstGeom>
-          <a:noFill/>
-        </p:spPr>
-        <p:txBody>
-          <a:bodyPr wrap="square" lIns="45720" rIns="45720" tIns="27432" bIns="27432" anchor="t">
-            <a:spAutoFit/>
-          </a:bodyPr>
-          <a:lstStyle/>
-          <a:p>
-            <a:pPr algn="l"/>
-            <a:r>
-              <a:rPr sz="900" b="0">
-                <a:solidFill>
-                  <a:srgbClr val="64748B"/>
-                </a:solidFill>
-                <a:latin typeface="Segoe UI"/>
-              </a:rPr>
-              <a:t>CORE · Researcher (Critique) — ASEAN demand, NETR &amp; CRESS, peer moves (TNB/YTL/Sembcorp/AboitizPower), data-centre captive power thesis; sources auto-reviewed.</a:t>
-            </a:r>
-          </a:p>
-          <a:p>
-            <a:pPr algn="l"/>
-            <a:r>
-              <a:rPr sz="900" b="0">
-                <a:solidFill>
-                  <a:srgbClr val="64748B"/>
-                </a:solidFill>
-                <a:latin typeface="Segoe UI"/>
-              </a:rPr>
-              <a:t>STRETCH · Excel Copilot — turn the scan into a market-context comparison table for the appendix.</a:t>
-            </a:r>
-          </a:p>
-        </p:txBody>
-      </p:sp>
-      <p:sp>
-        <p:nvSpPr>
-          <p:cNvPr id="27" name="Rounded Rectangle 26"/>
-          <p:cNvSpPr/>
-          <p:nvPr/>
-        </p:nvSpPr>
-        <p:spPr>
-          <a:xfrm>
-            <a:off x="7955280" y="1371600"/>
-            <a:ext cx="3886200" cy="2423160"/>
-          </a:xfrm>
-          <a:prstGeom prst="roundRect">
-            <a:avLst/>
-          </a:prstGeom>
           <a:solidFill>
-            <a:srgbClr val="FFFFFF"/>
+            <a:srgbClr val="1E3A5F"/>
           </a:solidFill>
-          <a:ln w="9525">
-            <a:solidFill>
-              <a:srgbClr val="D1D9E6"/>
-            </a:solidFill>
+          <a:ln>
+            <a:noFill/>
           </a:ln>
         </p:spPr>
         <p:style>
@@ -4130,23 +4060,142 @@
       </p:sp>
       <p:sp>
         <p:nvSpPr>
-          <p:cNvPr id="28" name="Rectangle 27"/>
-          <p:cNvSpPr/>
+          <p:cNvPr id="26" name="TextBox 25"/>
+          <p:cNvSpPr txBox="1"/>
           <p:nvPr/>
         </p:nvSpPr>
         <p:spPr>
           <a:xfrm>
-            <a:off x="7955280" y="1371600"/>
-            <a:ext cx="3886200" cy="411480"/>
+            <a:off x="8119872" y="1463040"/>
+            <a:ext cx="3557016" cy="256032"/>
           </a:xfrm>
           <a:prstGeom prst="rect">
             <a:avLst/>
           </a:prstGeom>
+          <a:noFill/>
+        </p:spPr>
+        <p:txBody>
+          <a:bodyPr wrap="square" lIns="45720" rIns="45720" tIns="27432" bIns="27432" anchor="t">
+            <a:spAutoFit/>
+          </a:bodyPr>
+          <a:lstStyle/>
+          <a:p>
+            <a:pPr algn="l"/>
+            <a:r>
+              <a:rPr sz="1000" b="1">
+                <a:solidFill>
+                  <a:srgbClr val="FFFFFF"/>
+                </a:solidFill>
+                <a:latin typeface="Segoe UI"/>
+              </a:rPr>
+              <a:t>ANALYST  +  3 MORE</a:t>
+            </a:r>
+          </a:p>
+        </p:txBody>
+      </p:sp>
+      <p:sp>
+        <p:nvSpPr>
+          <p:cNvPr id="27" name="TextBox 26"/>
+          <p:cNvSpPr txBox="1"/>
+          <p:nvPr/>
+        </p:nvSpPr>
+        <p:spPr>
+          <a:xfrm>
+            <a:off x="8119872" y="1874520"/>
+            <a:ext cx="3611880" cy="320040"/>
+          </a:xfrm>
+          <a:prstGeom prst="rect">
+            <a:avLst/>
+          </a:prstGeom>
+          <a:noFill/>
+        </p:spPr>
+        <p:txBody>
+          <a:bodyPr wrap="square" lIns="45720" rIns="45720" tIns="27432" bIns="27432" anchor="t">
+            <a:spAutoFit/>
+          </a:bodyPr>
+          <a:lstStyle/>
+          <a:p>
+            <a:pPr algn="l"/>
+            <a:r>
+              <a:rPr sz="1250" b="1">
+                <a:solidFill>
+                  <a:srgbClr val="1A202C"/>
+                </a:solidFill>
+                <a:latin typeface="Segoe UI"/>
+              </a:rPr>
+              <a:t>Financial benchmark + CFO pre-board</a:t>
+            </a:r>
+          </a:p>
+        </p:txBody>
+      </p:sp>
+      <p:sp>
+        <p:nvSpPr>
+          <p:cNvPr id="28" name="TextBox 27"/>
+          <p:cNvSpPr txBox="1"/>
+          <p:nvPr/>
+        </p:nvSpPr>
+        <p:spPr>
+          <a:xfrm>
+            <a:off x="8119872" y="2212848"/>
+            <a:ext cx="3611880" cy="1508760"/>
+          </a:xfrm>
+          <a:prstGeom prst="rect">
+            <a:avLst/>
+          </a:prstGeom>
+          <a:noFill/>
+        </p:spPr>
+        <p:txBody>
+          <a:bodyPr wrap="square" lIns="45720" rIns="45720" tIns="27432" bIns="27432" anchor="t">
+            <a:spAutoFit/>
+          </a:bodyPr>
+          <a:lstStyle/>
+          <a:p>
+            <a:pPr algn="l"/>
+            <a:r>
+              <a:rPr sz="950" b="0">
+                <a:solidFill>
+                  <a:srgbClr val="64748B"/>
+                </a:solidFill>
+                <a:latin typeface="Segoe UI"/>
+              </a:rPr>
+              <a:t>CORE · Analyst — EV/EBITDA, leverage, renewables mix vs peers; Group P&amp;L trend; plain-English commentary for non-financial directors.</a:t>
+            </a:r>
+          </a:p>
+          <a:p>
+            <a:pPr algn="l"/>
+            <a:r>
+              <a:rPr sz="950" b="0">
+                <a:solidFill>
+                  <a:srgbClr val="64748B"/>
+                </a:solidFill>
+                <a:latin typeface="Segoe UI"/>
+              </a:rPr>
+              <a:t>STRETCH · Teams Recap of the CFO pre-board call → Word Copilot formal notes  ·  Planner agent — Board Q&amp;A tracker.</a:t>
+            </a:r>
+          </a:p>
+        </p:txBody>
+      </p:sp>
+      <p:sp>
+        <p:nvSpPr>
+          <p:cNvPr id="29" name="Rounded Rectangle 28"/>
+          <p:cNvSpPr/>
+          <p:nvPr/>
+        </p:nvSpPr>
+        <p:spPr>
+          <a:xfrm>
+            <a:off x="3931920" y="3977640"/>
+            <a:ext cx="3886200" cy="2423160"/>
+          </a:xfrm>
+          <a:prstGeom prst="roundRect">
+            <a:avLst/>
+          </a:prstGeom>
           <a:solidFill>
-            <a:srgbClr val="1E3A5F"/>
+            <a:srgbClr val="FFFFFF"/>
           </a:solidFill>
-          <a:ln>
-            <a:noFill/>
+          <a:ln w="9525">
+            <a:solidFill>
+              <a:srgbClr val="D1D9E6"/>
+            </a:solidFill>
           </a:ln>
         </p:spPr>
         <p:style>
@@ -4173,90 +4222,20 @@
       </p:sp>
       <p:sp>
         <p:nvSpPr>
-          <p:cNvPr id="29" name="TextBox 28"/>
-          <p:cNvSpPr txBox="1"/>
+          <p:cNvPr id="30" name="Rectangle 29"/>
+          <p:cNvSpPr/>
           <p:nvPr/>
         </p:nvSpPr>
         <p:spPr>
           <a:xfrm>
-            <a:off x="8092440" y="1444752"/>
-            <a:ext cx="457200" cy="274320"/>
+            <a:off x="3931920" y="3977640"/>
+            <a:ext cx="3886200" cy="411480"/>
           </a:xfrm>
           <a:prstGeom prst="rect">
             <a:avLst/>
           </a:prstGeom>
-          <a:noFill/>
-        </p:spPr>
-        <p:txBody>
-          <a:bodyPr wrap="square" lIns="45720" rIns="45720" tIns="27432" bIns="27432" anchor="t">
-            <a:spAutoFit/>
-          </a:bodyPr>
-          <a:lstStyle/>
-          <a:p>
-            <a:pPr algn="l"/>
-            <a:r>
-              <a:rPr sz="1300" b="1">
-                <a:solidFill>
-                  <a:srgbClr val="FFFFFF"/>
-                </a:solidFill>
-                <a:latin typeface="Segoe UI"/>
-              </a:rPr>
-              <a:t>02</a:t>
-            </a:r>
-          </a:p>
-        </p:txBody>
-      </p:sp>
-      <p:sp>
-        <p:nvSpPr>
-          <p:cNvPr id="30" name="TextBox 29"/>
-          <p:cNvSpPr txBox="1"/>
-          <p:nvPr/>
-        </p:nvSpPr>
-        <p:spPr>
-          <a:xfrm>
-            <a:off x="8503920" y="1472184"/>
-            <a:ext cx="2514600" cy="256032"/>
-          </a:xfrm>
-          <a:prstGeom prst="rect">
-            <a:avLst/>
-          </a:prstGeom>
-          <a:noFill/>
-        </p:spPr>
-        <p:txBody>
-          <a:bodyPr wrap="square" lIns="45720" rIns="45720" tIns="27432" bIns="27432" anchor="t">
-            <a:spAutoFit/>
-          </a:bodyPr>
-          <a:lstStyle/>
-          <a:p>
-            <a:pPr algn="l"/>
-            <a:r>
-              <a:rPr sz="900" b="1">
-                <a:solidFill>
-                  <a:srgbClr val="FFFFFF"/>
-                </a:solidFill>
-                <a:latin typeface="Segoe UI"/>
-              </a:rPr>
-              <a:t>ANALYST  +  3 MORE</a:t>
-            </a:r>
-          </a:p>
-        </p:txBody>
-      </p:sp>
-      <p:sp>
-        <p:nvSpPr>
-          <p:cNvPr id="31" name="Rounded Rectangle 30"/>
-          <p:cNvSpPr/>
-          <p:nvPr/>
-        </p:nvSpPr>
-        <p:spPr>
-          <a:xfrm>
-            <a:off x="10972800" y="1453896"/>
-            <a:ext cx="731520" cy="256032"/>
-          </a:xfrm>
-          <a:prstGeom prst="roundRect">
-            <a:avLst/>
-          </a:prstGeom>
           <a:solidFill>
-            <a:srgbClr val="FFFFFF"/>
+            <a:srgbClr val="0E7490"/>
           </a:solidFill>
           <a:ln>
             <a:noFill/>
@@ -4286,14 +4265,14 @@
       </p:sp>
       <p:sp>
         <p:nvSpPr>
-          <p:cNvPr id="32" name="TextBox 31"/>
+          <p:cNvPr id="31" name="TextBox 30"/>
           <p:cNvSpPr txBox="1"/>
           <p:nvPr/>
         </p:nvSpPr>
         <p:spPr>
           <a:xfrm>
-            <a:off x="10972800" y="1463040"/>
-            <a:ext cx="731520" cy="246888"/>
+            <a:off x="4096512" y="4069080"/>
+            <a:ext cx="3557016" cy="256032"/>
           </a:xfrm>
           <a:prstGeom prst="rect">
             <a:avLst/>
@@ -4301,33 +4280,33 @@
           <a:noFill/>
         </p:spPr>
         <p:txBody>
-          <a:bodyPr wrap="square" lIns="45720" rIns="45720" tIns="27432" bIns="27432" anchor="ctr">
+          <a:bodyPr wrap="square" lIns="45720" rIns="45720" tIns="27432" bIns="27432" anchor="t">
             <a:spAutoFit/>
           </a:bodyPr>
           <a:lstStyle/>
           <a:p>
-            <a:pPr algn="ctr"/>
-            <a:r>
-              <a:rPr sz="850" b="1">
-                <a:solidFill>
-                  <a:srgbClr val="1E3A5F"/>
+            <a:pPr algn="l"/>
+            <a:r>
+              <a:rPr sz="1000" b="1">
+                <a:solidFill>
+                  <a:srgbClr val="FFFFFF"/>
                 </a:solidFill>
                 <a:latin typeface="Segoe UI"/>
               </a:rPr>
-              <a:t>25 min</a:t>
-            </a:r>
-          </a:p>
-        </p:txBody>
-      </p:sp>
-      <p:sp>
-        <p:nvSpPr>
-          <p:cNvPr id="33" name="TextBox 32"/>
+              <a:t>WORD  +  4 MORE</a:t>
+            </a:r>
+          </a:p>
+        </p:txBody>
+      </p:sp>
+      <p:sp>
+        <p:nvSpPr>
+          <p:cNvPr id="32" name="TextBox 31"/>
           <p:cNvSpPr txBox="1"/>
           <p:nvPr/>
         </p:nvSpPr>
         <p:spPr>
           <a:xfrm>
-            <a:off x="8119872" y="1874520"/>
+            <a:off x="4096512" y="4480560"/>
             <a:ext cx="3611880" cy="320040"/>
           </a:xfrm>
           <a:prstGeom prst="rect">
@@ -4343,26 +4322,26 @@
           <a:p>
             <a:pPr algn="l"/>
             <a:r>
-              <a:rPr sz="1200" b="1">
+              <a:rPr sz="1250" b="1">
                 <a:solidFill>
                   <a:srgbClr val="1A202C"/>
                 </a:solidFill>
                 <a:latin typeface="Segoe UI"/>
               </a:rPr>
-              <a:t>Financial benchmark + CFO pre-board</a:t>
-            </a:r>
-          </a:p>
-        </p:txBody>
-      </p:sp>
-      <p:sp>
-        <p:nvSpPr>
-          <p:cNvPr id="34" name="TextBox 33"/>
+              <a:t>Board paper · Renewables JV</a:t>
+            </a:r>
+          </a:p>
+        </p:txBody>
+      </p:sp>
+      <p:sp>
+        <p:nvSpPr>
+          <p:cNvPr id="33" name="TextBox 32"/>
           <p:cNvSpPr txBox="1"/>
           <p:nvPr/>
         </p:nvSpPr>
         <p:spPr>
           <a:xfrm>
-            <a:off x="8119872" y="2212848"/>
+            <a:off x="4096512" y="4818888"/>
             <a:ext cx="3611880" cy="1508760"/>
           </a:xfrm>
           <a:prstGeom prst="rect">
@@ -4378,38 +4357,38 @@
           <a:p>
             <a:pPr algn="l"/>
             <a:r>
-              <a:rPr sz="900" b="0">
+              <a:rPr sz="950" b="0">
                 <a:solidFill>
                   <a:srgbClr val="64748B"/>
                 </a:solidFill>
                 <a:latin typeface="Segoe UI"/>
               </a:rPr>
-              <a:t>CORE · Analyst — EV/EBITDA, leverage, renewables mix vs peers; Group P&amp;L trend; plain-English commentary for non-financial directors.</a:t>
+              <a:t>CORE · Word Copilot — 500 MW solar + 200 MWh BESS board paper grounded on the scan, with Legal regulatory overlay.</a:t>
             </a:r>
           </a:p>
           <a:p>
             <a:pPr algn="l"/>
             <a:r>
-              <a:rPr sz="900" b="0">
+              <a:rPr sz="950" b="0">
                 <a:solidFill>
                   <a:srgbClr val="64748B"/>
                 </a:solidFill>
                 <a:latin typeface="Segoe UI"/>
               </a:rPr>
-              <a:t>STRETCH · Teams Recap of the CFO pre-board call → Word Copilot formal notes  ·  Planner agent — Board Q&amp;A tracker.</a:t>
-            </a:r>
-          </a:p>
-        </p:txBody>
-      </p:sp>
-      <p:sp>
-        <p:nvSpPr>
-          <p:cNvPr id="35" name="Rounded Rectangle 34"/>
+              <a:t>STRETCH · PowerPoint agent — 10-slide board deck  ·  Excel agent — financial summary workbook  ·  Word agent — one-shot alt draft  ·  PowerPoint Copilot — in-app deck refinement.</a:t>
+            </a:r>
+          </a:p>
+        </p:txBody>
+      </p:sp>
+      <p:sp>
+        <p:nvSpPr>
+          <p:cNvPr id="34" name="Rounded Rectangle 33"/>
           <p:cNvSpPr/>
           <p:nvPr/>
         </p:nvSpPr>
         <p:spPr>
           <a:xfrm>
-            <a:off x="3931920" y="3977640"/>
+            <a:off x="7955280" y="3977640"/>
             <a:ext cx="3886200" cy="2423160"/>
           </a:xfrm>
           <a:prstGeom prst="roundRect">
@@ -4448,20 +4427,20 @@
       </p:sp>
       <p:sp>
         <p:nvSpPr>
-          <p:cNvPr id="36" name="Rectangle 35"/>
+          <p:cNvPr id="35" name="Rectangle 34"/>
           <p:cNvSpPr/>
           <p:nvPr/>
         </p:nvSpPr>
         <p:spPr>
           <a:xfrm>
-            <a:off x="3931920" y="3977640"/>
+            <a:off x="7955280" y="3977640"/>
             <a:ext cx="3886200" cy="411480"/>
           </a:xfrm>
           <a:prstGeom prst="rect">
             <a:avLst/>
           </a:prstGeom>
           <a:solidFill>
-            <a:srgbClr val="0E7490"/>
+            <a:srgbClr val="D97706"/>
           </a:solidFill>
           <a:ln>
             <a:noFill/>
@@ -4491,14 +4470,14 @@
       </p:sp>
       <p:sp>
         <p:nvSpPr>
-          <p:cNvPr id="37" name="TextBox 36"/>
+          <p:cNvPr id="36" name="TextBox 35"/>
           <p:cNvSpPr txBox="1"/>
           <p:nvPr/>
         </p:nvSpPr>
         <p:spPr>
           <a:xfrm>
-            <a:off x="4069080" y="4050792"/>
-            <a:ext cx="457200" cy="274320"/>
+            <a:off x="8119872" y="4069080"/>
+            <a:ext cx="3557016" cy="256032"/>
           </a:xfrm>
           <a:prstGeom prst="rect">
             <a:avLst/>
@@ -4513,27 +4492,27 @@
           <a:p>
             <a:pPr algn="l"/>
             <a:r>
-              <a:rPr sz="1300" b="1">
+              <a:rPr sz="1000" b="1">
                 <a:solidFill>
                   <a:srgbClr val="FFFFFF"/>
                 </a:solidFill>
                 <a:latin typeface="Segoe UI"/>
               </a:rPr>
-              <a:t>03</a:t>
-            </a:r>
-          </a:p>
-        </p:txBody>
-      </p:sp>
-      <p:sp>
-        <p:nvSpPr>
-          <p:cNvPr id="38" name="TextBox 37"/>
+              <a:t>COWORK</a:t>
+            </a:r>
+          </a:p>
+        </p:txBody>
+      </p:sp>
+      <p:sp>
+        <p:nvSpPr>
+          <p:cNvPr id="37" name="TextBox 36"/>
           <p:cNvSpPr txBox="1"/>
           <p:nvPr/>
         </p:nvSpPr>
         <p:spPr>
           <a:xfrm>
-            <a:off x="4480560" y="4078224"/>
-            <a:ext cx="2514600" cy="256032"/>
+            <a:off x="8119872" y="4480560"/>
+            <a:ext cx="3611880" cy="320040"/>
           </a:xfrm>
           <a:prstGeom prst="rect">
             <a:avLst/>
@@ -4548,70 +4527,27 @@
           <a:p>
             <a:pPr algn="l"/>
             <a:r>
-              <a:rPr sz="900" b="1">
-                <a:solidFill>
-                  <a:srgbClr val="FFFFFF"/>
+              <a:rPr sz="1250" b="1">
+                <a:solidFill>
+                  <a:srgbClr val="1A202C"/>
                 </a:solidFill>
                 <a:latin typeface="Segoe UI"/>
               </a:rPr>
-              <a:t>WORD  +  4 MORE</a:t>
-            </a:r>
-          </a:p>
-        </p:txBody>
-      </p:sp>
-      <p:sp>
-        <p:nvSpPr>
-          <p:cNvPr id="39" name="Rounded Rectangle 38"/>
-          <p:cNvSpPr/>
-          <p:nvPr/>
-        </p:nvSpPr>
-        <p:spPr>
-          <a:xfrm>
-            <a:off x="6949440" y="4059936"/>
-            <a:ext cx="731520" cy="256032"/>
-          </a:xfrm>
-          <a:prstGeom prst="roundRect">
-            <a:avLst/>
-          </a:prstGeom>
-          <a:solidFill>
-            <a:srgbClr val="FFFFFF"/>
-          </a:solidFill>
-          <a:ln>
-            <a:noFill/>
-          </a:ln>
-        </p:spPr>
-        <p:style>
-          <a:lnRef idx="1">
-            <a:schemeClr val="accent1"/>
-          </a:lnRef>
-          <a:fillRef idx="3">
-            <a:schemeClr val="accent1"/>
-          </a:fillRef>
-          <a:effectRef idx="2">
-            <a:schemeClr val="accent1"/>
-          </a:effectRef>
-          <a:fontRef idx="minor">
-            <a:schemeClr val="lt1"/>
-          </a:fontRef>
-        </p:style>
-        <p:txBody>
-          <a:bodyPr rtlCol="0" anchor="ctr"/>
-          <a:lstStyle/>
-          <a:p>
-            <a:pPr algn="ctr"/>
-          </a:p>
-        </p:txBody>
-      </p:sp>
-      <p:sp>
-        <p:nvSpPr>
-          <p:cNvPr id="40" name="TextBox 39"/>
+              <a:t>Investor pack + executive dashboard</a:t>
+            </a:r>
+          </a:p>
+        </p:txBody>
+      </p:sp>
+      <p:sp>
+        <p:nvSpPr>
+          <p:cNvPr id="38" name="TextBox 37"/>
           <p:cNvSpPr txBox="1"/>
           <p:nvPr/>
         </p:nvSpPr>
         <p:spPr>
           <a:xfrm>
-            <a:off x="6949440" y="4069080"/>
-            <a:ext cx="731520" cy="246888"/>
+            <a:off x="8119872" y="4818888"/>
+            <a:ext cx="3611880" cy="1508760"/>
           </a:xfrm>
           <a:prstGeom prst="rect">
             <a:avLst/>
@@ -4619,41 +4555,6 @@
           <a:noFill/>
         </p:spPr>
         <p:txBody>
-          <a:bodyPr wrap="square" lIns="45720" rIns="45720" tIns="27432" bIns="27432" anchor="ctr">
-            <a:spAutoFit/>
-          </a:bodyPr>
-          <a:lstStyle/>
-          <a:p>
-            <a:pPr algn="ctr"/>
-            <a:r>
-              <a:rPr sz="850" b="1">
-                <a:solidFill>
-                  <a:srgbClr val="0E7490"/>
-                </a:solidFill>
-                <a:latin typeface="Segoe UI"/>
-              </a:rPr>
-              <a:t>30 min</a:t>
-            </a:r>
-          </a:p>
-        </p:txBody>
-      </p:sp>
-      <p:sp>
-        <p:nvSpPr>
-          <p:cNvPr id="41" name="TextBox 40"/>
-          <p:cNvSpPr txBox="1"/>
-          <p:nvPr/>
-        </p:nvSpPr>
-        <p:spPr>
-          <a:xfrm>
-            <a:off x="4096512" y="4480560"/>
-            <a:ext cx="3611880" cy="320040"/>
-          </a:xfrm>
-          <a:prstGeom prst="rect">
-            <a:avLst/>
-          </a:prstGeom>
-          <a:noFill/>
-        </p:spPr>
-        <p:txBody>
           <a:bodyPr wrap="square" lIns="45720" rIns="45720" tIns="27432" bIns="27432" anchor="t">
             <a:spAutoFit/>
           </a:bodyPr>
@@ -4661,360 +4562,7 @@
           <a:p>
             <a:pPr algn="l"/>
             <a:r>
-              <a:rPr sz="1200" b="1">
-                <a:solidFill>
-                  <a:srgbClr val="1A202C"/>
-                </a:solidFill>
-                <a:latin typeface="Segoe UI"/>
-              </a:rPr>
-              <a:t>Board paper · Renewables JV</a:t>
-            </a:r>
-          </a:p>
-        </p:txBody>
-      </p:sp>
-      <p:sp>
-        <p:nvSpPr>
-          <p:cNvPr id="42" name="TextBox 41"/>
-          <p:cNvSpPr txBox="1"/>
-          <p:nvPr/>
-        </p:nvSpPr>
-        <p:spPr>
-          <a:xfrm>
-            <a:off x="4096512" y="4818888"/>
-            <a:ext cx="3611880" cy="1508760"/>
-          </a:xfrm>
-          <a:prstGeom prst="rect">
-            <a:avLst/>
-          </a:prstGeom>
-          <a:noFill/>
-        </p:spPr>
-        <p:txBody>
-          <a:bodyPr wrap="square" lIns="45720" rIns="45720" tIns="27432" bIns="27432" anchor="t">
-            <a:spAutoFit/>
-          </a:bodyPr>
-          <a:lstStyle/>
-          <a:p>
-            <a:pPr algn="l"/>
-            <a:r>
-              <a:rPr sz="900" b="0">
-                <a:solidFill>
-                  <a:srgbClr val="64748B"/>
-                </a:solidFill>
-                <a:latin typeface="Segoe UI"/>
-              </a:rPr>
-              <a:t>CORE · Word Copilot — 500 MW solar + 200 MWh BESS board paper grounded on the scan, with Legal regulatory overlay.</a:t>
-            </a:r>
-          </a:p>
-          <a:p>
-            <a:pPr algn="l"/>
-            <a:r>
-              <a:rPr sz="900" b="0">
-                <a:solidFill>
-                  <a:srgbClr val="64748B"/>
-                </a:solidFill>
-                <a:latin typeface="Segoe UI"/>
-              </a:rPr>
-              <a:t>STRETCH · PowerPoint agent — 10-slide board deck  ·  Excel agent — financial summary workbook  ·  Word agent — one-shot alt draft  ·  PowerPoint Copilot — in-app deck refinement.</a:t>
-            </a:r>
-          </a:p>
-        </p:txBody>
-      </p:sp>
-      <p:sp>
-        <p:nvSpPr>
-          <p:cNvPr id="43" name="Rounded Rectangle 42"/>
-          <p:cNvSpPr/>
-          <p:nvPr/>
-        </p:nvSpPr>
-        <p:spPr>
-          <a:xfrm>
-            <a:off x="7955280" y="3977640"/>
-            <a:ext cx="3886200" cy="2423160"/>
-          </a:xfrm>
-          <a:prstGeom prst="roundRect">
-            <a:avLst/>
-          </a:prstGeom>
-          <a:solidFill>
-            <a:srgbClr val="FFFFFF"/>
-          </a:solidFill>
-          <a:ln w="9525">
-            <a:solidFill>
-              <a:srgbClr val="D1D9E6"/>
-            </a:solidFill>
-          </a:ln>
-        </p:spPr>
-        <p:style>
-          <a:lnRef idx="1">
-            <a:schemeClr val="accent1"/>
-          </a:lnRef>
-          <a:fillRef idx="3">
-            <a:schemeClr val="accent1"/>
-          </a:fillRef>
-          <a:effectRef idx="2">
-            <a:schemeClr val="accent1"/>
-          </a:effectRef>
-          <a:fontRef idx="minor">
-            <a:schemeClr val="lt1"/>
-          </a:fontRef>
-        </p:style>
-        <p:txBody>
-          <a:bodyPr rtlCol="0" anchor="ctr"/>
-          <a:lstStyle/>
-          <a:p>
-            <a:pPr algn="ctr"/>
-          </a:p>
-        </p:txBody>
-      </p:sp>
-      <p:sp>
-        <p:nvSpPr>
-          <p:cNvPr id="44" name="Rectangle 43"/>
-          <p:cNvSpPr/>
-          <p:nvPr/>
-        </p:nvSpPr>
-        <p:spPr>
-          <a:xfrm>
-            <a:off x="7955280" y="3977640"/>
-            <a:ext cx="3886200" cy="411480"/>
-          </a:xfrm>
-          <a:prstGeom prst="rect">
-            <a:avLst/>
-          </a:prstGeom>
-          <a:solidFill>
-            <a:srgbClr val="D97706"/>
-          </a:solidFill>
-          <a:ln>
-            <a:noFill/>
-          </a:ln>
-        </p:spPr>
-        <p:style>
-          <a:lnRef idx="1">
-            <a:schemeClr val="accent1"/>
-          </a:lnRef>
-          <a:fillRef idx="3">
-            <a:schemeClr val="accent1"/>
-          </a:fillRef>
-          <a:effectRef idx="2">
-            <a:schemeClr val="accent1"/>
-          </a:effectRef>
-          <a:fontRef idx="minor">
-            <a:schemeClr val="lt1"/>
-          </a:fontRef>
-        </p:style>
-        <p:txBody>
-          <a:bodyPr rtlCol="0" anchor="ctr"/>
-          <a:lstStyle/>
-          <a:p>
-            <a:pPr algn="ctr"/>
-          </a:p>
-        </p:txBody>
-      </p:sp>
-      <p:sp>
-        <p:nvSpPr>
-          <p:cNvPr id="45" name="TextBox 44"/>
-          <p:cNvSpPr txBox="1"/>
-          <p:nvPr/>
-        </p:nvSpPr>
-        <p:spPr>
-          <a:xfrm>
-            <a:off x="8092440" y="4050792"/>
-            <a:ext cx="457200" cy="274320"/>
-          </a:xfrm>
-          <a:prstGeom prst="rect">
-            <a:avLst/>
-          </a:prstGeom>
-          <a:noFill/>
-        </p:spPr>
-        <p:txBody>
-          <a:bodyPr wrap="square" lIns="45720" rIns="45720" tIns="27432" bIns="27432" anchor="t">
-            <a:spAutoFit/>
-          </a:bodyPr>
-          <a:lstStyle/>
-          <a:p>
-            <a:pPr algn="l"/>
-            <a:r>
-              <a:rPr sz="1300" b="1">
-                <a:solidFill>
-                  <a:srgbClr val="FFFFFF"/>
-                </a:solidFill>
-                <a:latin typeface="Segoe UI"/>
-              </a:rPr>
-              <a:t>04</a:t>
-            </a:r>
-          </a:p>
-        </p:txBody>
-      </p:sp>
-      <p:sp>
-        <p:nvSpPr>
-          <p:cNvPr id="46" name="TextBox 45"/>
-          <p:cNvSpPr txBox="1"/>
-          <p:nvPr/>
-        </p:nvSpPr>
-        <p:spPr>
-          <a:xfrm>
-            <a:off x="8503920" y="4078224"/>
-            <a:ext cx="2514600" cy="256032"/>
-          </a:xfrm>
-          <a:prstGeom prst="rect">
-            <a:avLst/>
-          </a:prstGeom>
-          <a:noFill/>
-        </p:spPr>
-        <p:txBody>
-          <a:bodyPr wrap="square" lIns="45720" rIns="45720" tIns="27432" bIns="27432" anchor="t">
-            <a:spAutoFit/>
-          </a:bodyPr>
-          <a:lstStyle/>
-          <a:p>
-            <a:pPr algn="l"/>
-            <a:r>
-              <a:rPr sz="900" b="1">
-                <a:solidFill>
-                  <a:srgbClr val="FFFFFF"/>
-                </a:solidFill>
-                <a:latin typeface="Segoe UI"/>
-              </a:rPr>
-              <a:t>COWORK</a:t>
-            </a:r>
-          </a:p>
-        </p:txBody>
-      </p:sp>
-      <p:sp>
-        <p:nvSpPr>
-          <p:cNvPr id="47" name="Rounded Rectangle 46"/>
-          <p:cNvSpPr/>
-          <p:nvPr/>
-        </p:nvSpPr>
-        <p:spPr>
-          <a:xfrm>
-            <a:off x="10972800" y="4059936"/>
-            <a:ext cx="731520" cy="256032"/>
-          </a:xfrm>
-          <a:prstGeom prst="roundRect">
-            <a:avLst/>
-          </a:prstGeom>
-          <a:solidFill>
-            <a:srgbClr val="FFFFFF"/>
-          </a:solidFill>
-          <a:ln>
-            <a:noFill/>
-          </a:ln>
-        </p:spPr>
-        <p:style>
-          <a:lnRef idx="1">
-            <a:schemeClr val="accent1"/>
-          </a:lnRef>
-          <a:fillRef idx="3">
-            <a:schemeClr val="accent1"/>
-          </a:fillRef>
-          <a:effectRef idx="2">
-            <a:schemeClr val="accent1"/>
-          </a:effectRef>
-          <a:fontRef idx="minor">
-            <a:schemeClr val="lt1"/>
-          </a:fontRef>
-        </p:style>
-        <p:txBody>
-          <a:bodyPr rtlCol="0" anchor="ctr"/>
-          <a:lstStyle/>
-          <a:p>
-            <a:pPr algn="ctr"/>
-          </a:p>
-        </p:txBody>
-      </p:sp>
-      <p:sp>
-        <p:nvSpPr>
-          <p:cNvPr id="48" name="TextBox 47"/>
-          <p:cNvSpPr txBox="1"/>
-          <p:nvPr/>
-        </p:nvSpPr>
-        <p:spPr>
-          <a:xfrm>
-            <a:off x="10972800" y="4069080"/>
-            <a:ext cx="731520" cy="246888"/>
-          </a:xfrm>
-          <a:prstGeom prst="rect">
-            <a:avLst/>
-          </a:prstGeom>
-          <a:noFill/>
-        </p:spPr>
-        <p:txBody>
-          <a:bodyPr wrap="square" lIns="45720" rIns="45720" tIns="27432" bIns="27432" anchor="ctr">
-            <a:spAutoFit/>
-          </a:bodyPr>
-          <a:lstStyle/>
-          <a:p>
-            <a:pPr algn="ctr"/>
-            <a:r>
-              <a:rPr sz="850" b="1">
-                <a:solidFill>
-                  <a:srgbClr val="D97706"/>
-                </a:solidFill>
-                <a:latin typeface="Segoe UI"/>
-              </a:rPr>
-              <a:t>20 min</a:t>
-            </a:r>
-          </a:p>
-        </p:txBody>
-      </p:sp>
-      <p:sp>
-        <p:nvSpPr>
-          <p:cNvPr id="49" name="TextBox 48"/>
-          <p:cNvSpPr txBox="1"/>
-          <p:nvPr/>
-        </p:nvSpPr>
-        <p:spPr>
-          <a:xfrm>
-            <a:off x="8119872" y="4480560"/>
-            <a:ext cx="3611880" cy="320040"/>
-          </a:xfrm>
-          <a:prstGeom prst="rect">
-            <a:avLst/>
-          </a:prstGeom>
-          <a:noFill/>
-        </p:spPr>
-        <p:txBody>
-          <a:bodyPr wrap="square" lIns="45720" rIns="45720" tIns="27432" bIns="27432" anchor="t">
-            <a:spAutoFit/>
-          </a:bodyPr>
-          <a:lstStyle/>
-          <a:p>
-            <a:pPr algn="l"/>
-            <a:r>
-              <a:rPr sz="1200" b="1">
-                <a:solidFill>
-                  <a:srgbClr val="1A202C"/>
-                </a:solidFill>
-                <a:latin typeface="Segoe UI"/>
-              </a:rPr>
-              <a:t>Investor pack + executive dashboard</a:t>
-            </a:r>
-          </a:p>
-        </p:txBody>
-      </p:sp>
-      <p:sp>
-        <p:nvSpPr>
-          <p:cNvPr id="50" name="TextBox 49"/>
-          <p:cNvSpPr txBox="1"/>
-          <p:nvPr/>
-        </p:nvSpPr>
-        <p:spPr>
-          <a:xfrm>
-            <a:off x="8119872" y="4818888"/>
-            <a:ext cx="3611880" cy="1508760"/>
-          </a:xfrm>
-          <a:prstGeom prst="rect">
-            <a:avLst/>
-          </a:prstGeom>
-          <a:noFill/>
-        </p:spPr>
-        <p:txBody>
-          <a:bodyPr wrap="square" lIns="45720" rIns="45720" tIns="27432" bIns="27432" anchor="t">
-            <a:spAutoFit/>
-          </a:bodyPr>
-          <a:lstStyle/>
-          <a:p>
-            <a:pPr algn="l"/>
-            <a:r>
-              <a:rPr sz="900" b="0">
+              <a:rPr sz="950" b="0">
                 <a:solidFill>
                   <a:srgbClr val="64748B"/>
                 </a:solidFill>
@@ -5027,7 +4575,7 @@
       </p:sp>
       <p:sp>
         <p:nvSpPr>
-          <p:cNvPr id="51" name="TextBox 50"/>
+          <p:cNvPr id="39" name="TextBox 38"/>
           <p:cNvSpPr txBox="1"/>
           <p:nvPr/>
         </p:nvSpPr>

</xml_diff>